<commit_message>
Team page, and the team on the proposal deck and the submission text
</commit_message>
<xml_diff>
--- a/docs/submission/DNext_proposal.pptx
+++ b/docs/submission/DNext_proposal.pptx
@@ -120,43 +120,43 @@
   <p:extLst>
     <p:ext uri="{521415D9-36F7-43E2-AB2F-B90AF26B5E84}">
       <p14:sectionLst xmlns:p14="http://schemas.microsoft.com/office/powerpoint/2010/main">
-        <p14:section name="Opening" id="{a4c33103-74d3-e86a-95fd-83c529c9cc5b}">
+        <p14:section name="Opening" id="{5730631a-e236-eb05-0a79-a40179be9d50}">
           <p14:sldIdLst>
             <p14:sldId id="256"/>
           </p14:sldIdLst>
         </p14:section>
-        <p14:section name="Problem and benefit" id="{361c1f2f-dd33-d238-e2b2-00620cb00677}">
+        <p14:section name="Problem and benefit" id="{724eb621-deda-59c5-3c60-970c7e9f4029}">
           <p14:sldIdLst>
             <p14:sldId id="257"/>
             <p14:sldId id="258"/>
           </p14:sldIdLst>
         </p14:section>
-        <p14:section name="The solution" id="{d6ec1b69-9bae-b2d1-776e-aa3650894a98}">
+        <p14:section name="The solution" id="{977180cc-5d34-02cc-da03-39d92e146619}">
           <p14:sldIdLst>
             <p14:sldId id="259"/>
             <p14:sldId id="260"/>
             <p14:sldId id="261"/>
           </p14:sldIdLst>
         </p14:section>
-        <p14:section name="How it works" id="{eda00759-ce69-ae2e-4c65-9d4373763d5e}">
+        <p14:section name="How it works" id="{920c9346-a0fc-6238-45a5-aea820cc24bf}">
           <p14:sldIdLst>
             <p14:sldId id="262"/>
             <p14:sldId id="263"/>
           </p14:sldIdLst>
         </p14:section>
-        <p14:section name="Community and action" id="{8a4022a2-897e-0cd8-a695-fd3ddd87c949}">
+        <p14:section name="Community and action" id="{3b1ad56e-b058-ad16-1272-fa0ef2ff0840}">
           <p14:sldIdLst>
             <p14:sldId id="264"/>
             <p14:sldId id="265"/>
           </p14:sldIdLst>
         </p14:section>
-        <p14:section name="Feasibility and scale" id="{d87be63b-ac06-e6b1-eaa1-f6debe2ba99a}">
+        <p14:section name="Feasibility and scale" id="{3de884eb-2299-6c0d-7129-d51f809b1a22}">
           <p14:sldIdLst>
             <p14:sldId id="266"/>
             <p14:sldId id="267"/>
           </p14:sldIdLst>
         </p14:section>
-        <p14:section name="Responsible and next" id="{4c0f43e5-ef60-fa0a-a322-ca6f392d43b7}">
+        <p14:section name="Responsible and next" id="{305bc087-a75e-a7cf-431e-058b1da424c5}">
           <p14:sldIdLst>
             <p14:sldId id="268"/>
             <p14:sldId id="269"/>
@@ -1916,8 +1916,8 @@
         </p:nvSpPr>
         <p:spPr>
           <a:xfrm>
-            <a:off x="731520" y="1737360"/>
-            <a:ext cx="7223760" cy="1828800"/>
+            <a:off x="731520" y="1280160"/>
+            <a:ext cx="7223760" cy="1097280"/>
           </a:xfrm>
           <a:prstGeom prst="rect">
             <a:avLst/>
@@ -1958,7 +1958,7 @@
         </p:nvSpPr>
         <p:spPr>
           <a:xfrm>
-            <a:off x="731520" y="3657600"/>
+            <a:off x="731520" y="2377440"/>
             <a:ext cx="6949440" cy="1280160"/>
           </a:xfrm>
           <a:prstGeom prst="rect">
@@ -2836,8 +2836,8 @@
         </p:nvSpPr>
         <p:spPr>
           <a:xfrm>
-            <a:off x="731520" y="1737360"/>
-            <a:ext cx="7223760" cy="1828800"/>
+            <a:off x="731520" y="1280160"/>
+            <a:ext cx="7223760" cy="1097280"/>
           </a:xfrm>
           <a:prstGeom prst="rect">
             <a:avLst/>
@@ -2877,7 +2877,7 @@
         </p:nvSpPr>
         <p:spPr>
           <a:xfrm>
-            <a:off x="731520" y="3657600"/>
+            <a:off x="731520" y="2377440"/>
             <a:ext cx="6949440" cy="1280160"/>
           </a:xfrm>
           <a:prstGeom prst="rect">
@@ -2916,7 +2916,7 @@
         </p:nvSpPr>
         <p:spPr>
           <a:xfrm>
-            <a:off x="731520" y="5166360"/>
+            <a:off x="731520" y="3931920"/>
             <a:ext cx="6949440" cy="960120"/>
           </a:xfrm>
           <a:prstGeom prst="roundRect">
@@ -2943,7 +2943,7 @@
         </p:nvSpPr>
         <p:spPr>
           <a:xfrm>
-            <a:off x="960120" y="5285232"/>
+            <a:off x="960120" y="4050792"/>
             <a:ext cx="6583680" cy="731520"/>
           </a:xfrm>
           <a:prstGeom prst="rect">
@@ -3019,9 +3019,109 @@
           </a:p>
         </p:txBody>
       </p:sp>
+      <p:sp>
+        <p:nvSpPr>
+          <p:cNvPr id="6" name="team card"/>
+          <p:cNvSpPr/>
+          <p:nvPr/>
+        </p:nvSpPr>
+        <p:spPr>
+          <a:xfrm>
+            <a:off x="731520" y="5120640"/>
+            <a:ext cx="6949440" cy="1097280"/>
+          </a:xfrm>
+          <a:prstGeom prst="roundRect">
+            <a:avLst>
+              <a:gd name="adj" fmla="val 6667"/>
+            </a:avLst>
+          </a:prstGeom>
+          <a:solidFill>
+            <a:schemeClr val="tx2"/>
+          </a:solidFill>
+          <a:ln w="9525">
+            <a:solidFill>
+              <a:schemeClr val="tx2"/>
+            </a:solidFill>
+            <a:prstDash val="solid"/>
+          </a:ln>
+        </p:spPr>
+      </p:sp>
+      <p:sp>
+        <p:nvSpPr>
+          <p:cNvPr id="7" name="Text 5"/>
+          <p:cNvSpPr txBox="1"/>
+          <p:nvPr/>
+        </p:nvSpPr>
+        <p:spPr>
+          <a:xfrm>
+            <a:off x="960120" y="5230368"/>
+            <a:ext cx="6583680" cy="914400"/>
+          </a:xfrm>
+          <a:prstGeom prst="rect">
+            <a:avLst/>
+          </a:prstGeom>
+          <a:noFill/>
+          <a:ln/>
+        </p:spPr>
+        <p:txBody>
+          <a:bodyPr wrap="square" lIns="0" tIns="0" rIns="0" bIns="0" rtlCol="0" anchor="t"/>
+          <a:lstStyle/>
+          <a:p>
+            <a:pPr indent="0" marL="0">
+              <a:buNone/>
+            </a:pPr>
+            <a:r>
+              <a:rPr lang="en-US" sz="1600" b="1" dirty="0">
+                <a:solidFill>
+                  <a:schemeClr val="bg1"/>
+                </a:solidFill>
+                <a:latin typeface="Georgia" pitchFamily="34" charset="0"/>
+                <a:ea typeface="Georgia" pitchFamily="34" charset="-122"/>
+                <a:cs typeface="Georgia" pitchFamily="34" charset="-120"/>
+              </a:rPr>
+              <a:t>DNext (Disaster Next) Team</a:t>
+            </a:r>
+            <a:endParaRPr lang="en-US" sz="1300" dirty="0"/>
+          </a:p>
+          <a:p>
+            <a:pPr indent="0" marL="0">
+              <a:buNone/>
+            </a:pPr>
+            <a:r>
+              <a:rPr lang="en-US" sz="1300" dirty="0">
+                <a:solidFill>
+                  <a:schemeClr val="bg1"/>
+                </a:solidFill>
+                <a:latin typeface="Arial" pitchFamily="34" charset="0"/>
+                <a:ea typeface="Arial" pitchFamily="34" charset="-122"/>
+                <a:cs typeface="Arial" pitchFamily="34" charset="-120"/>
+              </a:rPr>
+              <a:t>Kamal Hosen, Geospatial Application Developer</a:t>
+            </a:r>
+            <a:endParaRPr lang="en-US" sz="1300" dirty="0"/>
+          </a:p>
+          <a:p>
+            <a:pPr indent="0" marL="0">
+              <a:buNone/>
+            </a:pPr>
+            <a:r>
+              <a:rPr lang="en-US" sz="1300" dirty="0">
+                <a:solidFill>
+                  <a:schemeClr val="bg1"/>
+                </a:solidFill>
+                <a:latin typeface="Arial" pitchFamily="34" charset="0"/>
+                <a:ea typeface="Arial" pitchFamily="34" charset="-122"/>
+                <a:cs typeface="Arial" pitchFamily="34" charset="-120"/>
+              </a:rPr>
+              <a:t>Hafsah Ilmy, Geospatial Data Scientist (Landslide Model Developer)</a:t>
+            </a:r>
+            <a:endParaRPr lang="en-US" sz="1300" dirty="0"/>
+          </a:p>
+        </p:txBody>
+      </p:sp>
       <p:pic>
         <p:nvPicPr>
-          <p:cNvPr id="6" name="overview thumbnail" descr="National overview screen">    </p:cNvPr>
+          <p:cNvPr id="8" name="overview thumbnail" descr="National overview screen">    </p:cNvPr>
           <p:cNvPicPr>
             <a:picLocks noChangeAspect="1"/>
           </p:cNvPicPr>
@@ -3045,7 +3145,7 @@
       </p:pic>
       <p:pic>
         <p:nvPicPr>
-          <p:cNvPr id="7" name="3d thumbnail" descr="3D blocks of affected buildings">    </p:cNvPr>
+          <p:cNvPr id="9" name="3d thumbnail" descr="3D blocks of affected buildings">    </p:cNvPr>
           <p:cNvPicPr>
             <a:picLocks noChangeAspect="1"/>
           </p:cNvPicPr>
@@ -6730,12 +6830,12 @@
         </p:nvSpPr>
         <p:spPr>
           <a:xfrm>
-            <a:off x="548640" y="2880360"/>
-            <a:ext cx="3611880" cy="2331720"/>
+            <a:off x="548640" y="2788920"/>
+            <a:ext cx="3611880" cy="2011680"/>
           </a:xfrm>
           <a:prstGeom prst="roundRect">
             <a:avLst>
-              <a:gd name="adj" fmla="val 3137"/>
+              <a:gd name="adj" fmla="val 3636"/>
             </a:avLst>
           </a:prstGeom>
           <a:solidFill>
@@ -6757,7 +6857,7 @@
         </p:nvSpPr>
         <p:spPr>
           <a:xfrm>
-            <a:off x="822960" y="3108960"/>
+            <a:off x="822960" y="2971800"/>
             <a:ext cx="502920" cy="502920"/>
           </a:xfrm>
           <a:prstGeom prst="ellipse">
@@ -6782,7 +6882,7 @@
         </p:nvSpPr>
         <p:spPr>
           <a:xfrm>
-            <a:off x="822960" y="3108960"/>
+            <a:off x="822960" y="2971800"/>
             <a:ext cx="502920" cy="502920"/>
           </a:xfrm>
           <a:prstGeom prst="rect">
@@ -6821,7 +6921,7 @@
         </p:nvSpPr>
         <p:spPr>
           <a:xfrm>
-            <a:off x="1463040" y="3108960"/>
+            <a:off x="1463040" y="2971800"/>
             <a:ext cx="2560320" cy="502920"/>
           </a:xfrm>
           <a:prstGeom prst="rect">
@@ -6860,8 +6960,8 @@
         </p:nvSpPr>
         <p:spPr>
           <a:xfrm>
-            <a:off x="822960" y="3749040"/>
-            <a:ext cx="3108960" cy="1371600"/>
+            <a:off x="822960" y="3611880"/>
+            <a:ext cx="3108960" cy="1143000"/>
           </a:xfrm>
           <a:prstGeom prst="rect">
             <a:avLst/>
@@ -6877,7 +6977,7 @@
               <a:buNone/>
             </a:pPr>
             <a:r>
-              <a:rPr lang="en-US" sz="1400" dirty="0">
+              <a:rPr lang="en-US" sz="1300" dirty="0">
                 <a:solidFill>
                   <a:schemeClr val="bg2"/>
                 </a:solidFill>
@@ -6887,7 +6987,7 @@
               </a:rPr>
               <a:t>The national map and the 5-day forecast show without signing in. Press play.</a:t>
             </a:r>
-            <a:endParaRPr lang="en-US" sz="1400" dirty="0"/>
+            <a:endParaRPr lang="en-US" sz="1300" dirty="0"/>
           </a:p>
         </p:txBody>
       </p:sp>
@@ -6899,12 +6999,12 @@
         </p:nvSpPr>
         <p:spPr>
           <a:xfrm>
-            <a:off x="4343400" y="2880360"/>
-            <a:ext cx="3611880" cy="2331720"/>
+            <a:off x="4343400" y="2788920"/>
+            <a:ext cx="3611880" cy="2011680"/>
           </a:xfrm>
           <a:prstGeom prst="roundRect">
             <a:avLst>
-              <a:gd name="adj" fmla="val 3137"/>
+              <a:gd name="adj" fmla="val 3636"/>
             </a:avLst>
           </a:prstGeom>
           <a:solidFill>
@@ -6926,7 +7026,7 @@
         </p:nvSpPr>
         <p:spPr>
           <a:xfrm>
-            <a:off x="4617720" y="3108960"/>
+            <a:off x="4617720" y="2971800"/>
             <a:ext cx="502920" cy="502920"/>
           </a:xfrm>
           <a:prstGeom prst="ellipse">
@@ -6951,7 +7051,7 @@
         </p:nvSpPr>
         <p:spPr>
           <a:xfrm>
-            <a:off x="4617720" y="3108960"/>
+            <a:off x="4617720" y="2971800"/>
             <a:ext cx="502920" cy="502920"/>
           </a:xfrm>
           <a:prstGeom prst="rect">
@@ -6990,7 +7090,7 @@
         </p:nvSpPr>
         <p:spPr>
           <a:xfrm>
-            <a:off x="5257800" y="3108960"/>
+            <a:off x="5257800" y="2971800"/>
             <a:ext cx="2560320" cy="502920"/>
           </a:xfrm>
           <a:prstGeom prst="rect">
@@ -7029,8 +7129,8 @@
         </p:nvSpPr>
         <p:spPr>
           <a:xfrm>
-            <a:off x="4617720" y="3749040"/>
-            <a:ext cx="3108960" cy="1371600"/>
+            <a:off x="4617720" y="3611880"/>
+            <a:ext cx="3108960" cy="1143000"/>
           </a:xfrm>
           <a:prstGeom prst="rect">
             <a:avLst/>
@@ -7046,7 +7146,7 @@
               <a:buNone/>
             </a:pPr>
             <a:r>
-              <a:rPr lang="en-US" sz="1400" dirty="0">
+              <a:rPr lang="en-US" sz="1300" dirty="0">
                 <a:solidFill>
                   <a:schemeClr val="bg2"/>
                 </a:solidFill>
@@ -7056,7 +7156,7 @@
               </a:rPr>
               <a:t>Needed for chat, scenarios, routes and reports (per-account daily limits apply).</a:t>
             </a:r>
-            <a:endParaRPr lang="en-US" sz="1400" dirty="0"/>
+            <a:endParaRPr lang="en-US" sz="1300" dirty="0"/>
           </a:p>
         </p:txBody>
       </p:sp>
@@ -7068,12 +7168,12 @@
         </p:nvSpPr>
         <p:spPr>
           <a:xfrm>
-            <a:off x="8138160" y="2880360"/>
-            <a:ext cx="3611880" cy="2331720"/>
+            <a:off x="8138160" y="2788920"/>
+            <a:ext cx="3611880" cy="2011680"/>
           </a:xfrm>
           <a:prstGeom prst="roundRect">
             <a:avLst>
-              <a:gd name="adj" fmla="val 3137"/>
+              <a:gd name="adj" fmla="val 3636"/>
             </a:avLst>
           </a:prstGeom>
           <a:solidFill>
@@ -7095,7 +7195,7 @@
         </p:nvSpPr>
         <p:spPr>
           <a:xfrm>
-            <a:off x="8412480" y="3108960"/>
+            <a:off x="8412480" y="2971800"/>
             <a:ext cx="502920" cy="502920"/>
           </a:xfrm>
           <a:prstGeom prst="ellipse">
@@ -7120,7 +7220,7 @@
         </p:nvSpPr>
         <p:spPr>
           <a:xfrm>
-            <a:off x="8412480" y="3108960"/>
+            <a:off x="8412480" y="2971800"/>
             <a:ext cx="502920" cy="502920"/>
           </a:xfrm>
           <a:prstGeom prst="rect">
@@ -7159,7 +7259,7 @@
         </p:nvSpPr>
         <p:spPr>
           <a:xfrm>
-            <a:off x="9052560" y="3108960"/>
+            <a:off x="9052560" y="2971800"/>
             <a:ext cx="2560320" cy="502920"/>
           </a:xfrm>
           <a:prstGeom prst="rect">
@@ -7198,8 +7298,8 @@
         </p:nvSpPr>
         <p:spPr>
           <a:xfrm>
-            <a:off x="8412480" y="3749040"/>
-            <a:ext cx="3108960" cy="1371600"/>
+            <a:off x="8412480" y="3611880"/>
+            <a:ext cx="3108960" cy="1143000"/>
           </a:xfrm>
           <a:prstGeom prst="rect">
             <a:avLst/>
@@ -7215,7 +7315,7 @@
               <a:buNone/>
             </a:pPr>
             <a:r>
-              <a:rPr lang="en-US" sz="1400" dirty="0">
+              <a:rPr lang="en-US" sz="1300" dirty="0">
                 <a:solidFill>
                   <a:schemeClr val="bg2"/>
                 </a:solidFill>
@@ -7225,20 +7325,86 @@
               </a:rPr>
               <a:t>"What if 250 mm falls on Nan in 3 days?" · "Which provinces have the highest risk this week?" · "How many schools are at risk in Chon Buri?"</a:t>
             </a:r>
-            <a:endParaRPr lang="en-US" sz="1400" dirty="0"/>
-          </a:p>
-        </p:txBody>
-      </p:sp>
-      <p:sp>
-        <p:nvSpPr>
-          <p:cNvPr id="20" name="Text 18"/>
+            <a:endParaRPr lang="en-US" sz="1300" dirty="0"/>
+          </a:p>
+        </p:txBody>
+      </p:sp>
+      <p:sp>
+        <p:nvSpPr>
+          <p:cNvPr id="20" name="team strip"/>
+          <p:cNvSpPr/>
+          <p:nvPr/>
+        </p:nvSpPr>
+        <p:spPr>
+          <a:xfrm>
+            <a:off x="548640" y="4983480"/>
+            <a:ext cx="11109960" cy="960120"/>
+          </a:xfrm>
+          <a:prstGeom prst="roundRect">
+            <a:avLst>
+              <a:gd name="adj" fmla="val 7619"/>
+            </a:avLst>
+          </a:prstGeom>
+          <a:solidFill>
+            <a:schemeClr val="tx2"/>
+          </a:solidFill>
+          <a:ln w="9525">
+            <a:solidFill>
+              <a:schemeClr val="tx2"/>
+            </a:solidFill>
+            <a:prstDash val="solid"/>
+          </a:ln>
+        </p:spPr>
+      </p:sp>
+      <p:sp>
+        <p:nvSpPr>
+          <p:cNvPr id="21" name="Text 19"/>
           <p:cNvSpPr txBox="1"/>
           <p:nvPr/>
         </p:nvSpPr>
         <p:spPr>
           <a:xfrm>
-            <a:off x="548640" y="5486400"/>
-            <a:ext cx="11109960" cy="731520"/>
+            <a:off x="777240" y="5102352"/>
+            <a:ext cx="2743200" cy="731520"/>
+          </a:xfrm>
+          <a:prstGeom prst="rect">
+            <a:avLst/>
+          </a:prstGeom>
+          <a:noFill/>
+          <a:ln/>
+        </p:spPr>
+        <p:txBody>
+          <a:bodyPr wrap="square" lIns="0" tIns="0" rIns="0" bIns="0" rtlCol="0" anchor="ctr"/>
+          <a:lstStyle/>
+          <a:p>
+            <a:pPr indent="0" marL="0">
+              <a:buNone/>
+            </a:pPr>
+            <a:r>
+              <a:rPr lang="en-US" sz="1700" b="1" dirty="0">
+                <a:solidFill>
+                  <a:schemeClr val="bg1"/>
+                </a:solidFill>
+                <a:latin typeface="Georgia" pitchFamily="34" charset="0"/>
+                <a:ea typeface="Georgia" pitchFamily="34" charset="-122"/>
+                <a:cs typeface="Georgia" pitchFamily="34" charset="-120"/>
+              </a:rPr>
+              <a:t>DNext (Disaster Next) Team</a:t>
+            </a:r>
+            <a:endParaRPr lang="en-US" sz="1700" dirty="0"/>
+          </a:p>
+        </p:txBody>
+      </p:sp>
+      <p:sp>
+        <p:nvSpPr>
+          <p:cNvPr id="22" name="Text 20"/>
+          <p:cNvSpPr txBox="1"/>
+          <p:nvPr/>
+        </p:nvSpPr>
+        <p:spPr>
+          <a:xfrm>
+            <a:off x="3611880" y="5074920"/>
+            <a:ext cx="3657600" cy="822960"/>
           </a:xfrm>
           <a:prstGeom prst="rect">
             <a:avLst/>
@@ -7254,17 +7420,163 @@
               <a:buNone/>
             </a:pPr>
             <a:r>
-              <a:rPr lang="en-US" sz="1200" dirty="0">
-                <a:solidFill>
-                  <a:schemeClr val="bg2"/>
+              <a:rPr lang="en-US" sz="1200" b="1" dirty="0">
+                <a:solidFill>
+                  <a:schemeClr val="bg1"/>
                 </a:solidFill>
                 <a:latin typeface="Arial" pitchFamily="34" charset="0"/>
                 <a:ea typeface="Arial" pitchFamily="34" charset="-122"/>
                 <a:cs typeface="Arial" pitchFamily="34" charset="-120"/>
               </a:rPr>
+              <a:t>Kamal Hosen</a:t>
+            </a:r>
+            <a:endParaRPr lang="en-US" sz="1200" dirty="0"/>
+          </a:p>
+          <a:p>
+            <a:pPr indent="0" marL="0">
+              <a:buNone/>
+            </a:pPr>
+            <a:r>
+              <a:rPr lang="en-US" sz="1200" dirty="0">
+                <a:solidFill>
+                  <a:schemeClr val="bg1"/>
+                </a:solidFill>
+                <a:latin typeface="Arial" pitchFamily="34" charset="0"/>
+                <a:ea typeface="Arial" pitchFamily="34" charset="-122"/>
+                <a:cs typeface="Arial" pitchFamily="34" charset="-120"/>
+              </a:rPr>
+              <a:t>Geospatial Application Developer</a:t>
+            </a:r>
+            <a:endParaRPr lang="en-US" sz="1200" dirty="0"/>
+          </a:p>
+          <a:p>
+            <a:pPr indent="0" marL="0">
+              <a:buNone/>
+            </a:pPr>
+            <a:r>
+              <a:rPr lang="en-US" sz="1200" dirty="0">
+                <a:solidFill>
+                  <a:schemeClr val="bg1"/>
+                </a:solidFill>
+                <a:latin typeface="Arial" pitchFamily="34" charset="0"/>
+                <a:ea typeface="Arial" pitchFamily="34" charset="-122"/>
+                <a:cs typeface="Arial" pitchFamily="34" charset="-120"/>
+              </a:rPr>
+              <a:t>kamal.hosen@adpc.net</a:t>
+            </a:r>
+            <a:endParaRPr lang="en-US" sz="1200" dirty="0"/>
+          </a:p>
+        </p:txBody>
+      </p:sp>
+      <p:sp>
+        <p:nvSpPr>
+          <p:cNvPr id="23" name="Text 21"/>
+          <p:cNvSpPr txBox="1"/>
+          <p:nvPr/>
+        </p:nvSpPr>
+        <p:spPr>
+          <a:xfrm>
+            <a:off x="7452360" y="5074920"/>
+            <a:ext cx="4023360" cy="822960"/>
+          </a:xfrm>
+          <a:prstGeom prst="rect">
+            <a:avLst/>
+          </a:prstGeom>
+          <a:noFill/>
+          <a:ln/>
+        </p:spPr>
+        <p:txBody>
+          <a:bodyPr wrap="square" lIns="0" tIns="0" rIns="0" bIns="0" rtlCol="0" anchor="t"/>
+          <a:lstStyle/>
+          <a:p>
+            <a:pPr indent="0" marL="0">
+              <a:buNone/>
+            </a:pPr>
+            <a:r>
+              <a:rPr lang="en-US" sz="1200" b="1" dirty="0">
+                <a:solidFill>
+                  <a:schemeClr val="bg1"/>
+                </a:solidFill>
+                <a:latin typeface="Arial" pitchFamily="34" charset="0"/>
+                <a:ea typeface="Arial" pitchFamily="34" charset="-122"/>
+                <a:cs typeface="Arial" pitchFamily="34" charset="-120"/>
+              </a:rPr>
+              <a:t>Hafsah Ilmy</a:t>
+            </a:r>
+            <a:endParaRPr lang="en-US" sz="1200" dirty="0"/>
+          </a:p>
+          <a:p>
+            <a:pPr indent="0" marL="0">
+              <a:buNone/>
+            </a:pPr>
+            <a:r>
+              <a:rPr lang="en-US" sz="1200" dirty="0">
+                <a:solidFill>
+                  <a:schemeClr val="bg1"/>
+                </a:solidFill>
+                <a:latin typeface="Arial" pitchFamily="34" charset="0"/>
+                <a:ea typeface="Arial" pitchFamily="34" charset="-122"/>
+                <a:cs typeface="Arial" pitchFamily="34" charset="-120"/>
+              </a:rPr>
+              <a:t>Geospatial Data Scientist (Landslide Model Developer)</a:t>
+            </a:r>
+            <a:endParaRPr lang="en-US" sz="1200" dirty="0"/>
+          </a:p>
+          <a:p>
+            <a:pPr indent="0" marL="0">
+              <a:buNone/>
+            </a:pPr>
+            <a:r>
+              <a:rPr lang="en-US" sz="1200" dirty="0">
+                <a:solidFill>
+                  <a:schemeClr val="bg1"/>
+                </a:solidFill>
+                <a:latin typeface="Arial" pitchFamily="34" charset="0"/>
+                <a:ea typeface="Arial" pitchFamily="34" charset="-122"/>
+                <a:cs typeface="Arial" pitchFamily="34" charset="-120"/>
+              </a:rPr>
+              <a:t>hafsah.ilmy@adpc.net</a:t>
+            </a:r>
+            <a:endParaRPr lang="en-US" sz="1200" dirty="0"/>
+          </a:p>
+        </p:txBody>
+      </p:sp>
+      <p:sp>
+        <p:nvSpPr>
+          <p:cNvPr id="24" name="Text 22"/>
+          <p:cNvSpPr txBox="1"/>
+          <p:nvPr/>
+        </p:nvSpPr>
+        <p:spPr>
+          <a:xfrm>
+            <a:off x="548640" y="6080760"/>
+            <a:ext cx="11109960" cy="548640"/>
+          </a:xfrm>
+          <a:prstGeom prst="rect">
+            <a:avLst/>
+          </a:prstGeom>
+          <a:noFill/>
+          <a:ln/>
+        </p:spPr>
+        <p:txBody>
+          <a:bodyPr wrap="square" lIns="0" tIns="0" rIns="0" bIns="0" rtlCol="0" anchor="t"/>
+          <a:lstStyle/>
+          <a:p>
+            <a:pPr indent="0" marL="0">
+              <a:buNone/>
+            </a:pPr>
+            <a:r>
+              <a:rPr lang="en-US" sz="1000" dirty="0">
+                <a:solidFill>
+                  <a:schemeClr val="bg2"/>
+                </a:solidFill>
+                <a:latin typeface="Arial" pitchFamily="34" charset="0"/>
+                <a:ea typeface="Arial" pitchFamily="34" charset="-122"/>
+                <a:cs typeface="Arial" pitchFamily="34" charset="-120"/>
+              </a:rPr>
               <a:t>Theme: Sustainability &amp; Social Impact   ·   Category: Sustainability   ·   Google Cloud: Gemini on Vertex AI, Agent Development Kit, Earth Engine, Cloud Run, Firestore, BigQuery, Pub/Sub, Cloud Storage, Firebase Authentication, Google Maps Platform</a:t>
             </a:r>
-            <a:endParaRPr lang="en-US" sz="1200" dirty="0"/>
+            <a:endParaRPr lang="en-US" sz="1000" dirty="0"/>
           </a:p>
         </p:txBody>
       </p:sp>

</xml_diff>